<commit_message>
Add offer-letter data parser (person4-data-parser) + AI layer scaffold
Multi-layer, confidence-scored compensation data parser: input-tolerant
(raw text / pdfplumber / OCR fallback), spatial table extraction, strict
label regex with word-boundary matching, payroll-rule estimation, CTC
checksum validation, and red-flag/anomaly detection. Exposes a FastAPI
service (checklist, parse, list/filter, compare) backed by local SQLite
storage, with multi-offer comparison marking one-sided fields as "NA".

31 tests, including regressions for real bugs caught during development
(word-boundary false matches, an over-generic alias, a table-header false
positive) — all verified against real parser output, not hand-derived.

Also starts the AI orchestrator layer (ai/app/llm_client.py): a
provider-agnostic LLM interface with a keyless mock default and a Gemini
implementation ready to activate once a free-tier key exists.
</commit_message>
<xml_diff>
--- a/Financial-Clarity-Pitch-Deck.pptx
+++ b/Financial-Clarity-Pitch-Deck.pptx
@@ -134,7 +134,7 @@
   <pc:docChgLst>
     <pc:chgData name="Adhvik Reddy" userId="d417a314865503f0" providerId="LiveId" clId="{B1386EAD-4AA4-4BA3-8886-75E60B19B440}"/>
     <pc:docChg chg="undo custSel addSld delSld modSld">
-      <pc:chgData name="Adhvik Reddy" userId="d417a314865503f0" providerId="LiveId" clId="{B1386EAD-4AA4-4BA3-8886-75E60B19B440}" dt="2026-09-05T06:43:03.859" v="128" actId="207"/>
+      <pc:chgData name="Adhvik Reddy" userId="d417a314865503f0" providerId="LiveId" clId="{B1386EAD-4AA4-4BA3-8886-75E60B19B440}" dt="2026-09-05T09:23:56.493" v="130" actId="1076"/>
       <pc:docMkLst>
         <pc:docMk/>
       </pc:docMkLst>
@@ -303,6 +303,21 @@
             <pc:docMk/>
             <pc:sldMk cId="0" sldId="263"/>
             <ac:picMk id="10" creationId="{E34BDBF0-B003-6DEA-A7BC-75C2BBFA8F26}"/>
+          </ac:picMkLst>
+        </pc:picChg>
+      </pc:sldChg>
+      <pc:sldChg chg="modSp mod">
+        <pc:chgData name="Adhvik Reddy" userId="d417a314865503f0" providerId="LiveId" clId="{B1386EAD-4AA4-4BA3-8886-75E60B19B440}" dt="2026-09-05T09:23:56.493" v="130" actId="1076"/>
+        <pc:sldMkLst>
+          <pc:docMk/>
+          <pc:sldMk cId="0" sldId="264"/>
+        </pc:sldMkLst>
+        <pc:picChg chg="mod">
+          <ac:chgData name="Adhvik Reddy" userId="d417a314865503f0" providerId="LiveId" clId="{B1386EAD-4AA4-4BA3-8886-75E60B19B440}" dt="2026-09-05T09:23:56.493" v="130" actId="1076"/>
+          <ac:picMkLst>
+            <pc:docMk/>
+            <pc:sldMk cId="0" sldId="264"/>
+            <ac:picMk id="3" creationId="{00000000-0000-0000-0000-000000000000}"/>
           </ac:picMkLst>
         </pc:picChg>
       </pc:sldChg>
@@ -4214,7 +4229,7 @@
         </p:blipFill>
         <p:spPr>
           <a:xfrm>
-            <a:off x="661475" y="2698750"/>
+            <a:off x="670114" y="2694126"/>
             <a:ext cx="2632604" cy="895052"/>
           </a:xfrm>
           <a:prstGeom prst="rect">

</xml_diff>